<commit_message>
Sesión 10 Diapositiva 2: stop displaying answers to the cold-call questions
Showing the expected answer on screen right next to each question
defeated the point of picking students at random — anyone could just
read it off the slide. The cards now show only the four questions;
answers stay in the instructor's script (the bracketed hints in
"Lo que debes decir") and, going forward, in a separate answer-key PDF
shared with students after class.

Co-Authored-By: Claude Sonnet 5 <noreply@anthropic.com>
Claude-Session: https://claude.ai/code/session_01YYoLTm5E5BxGfUsceBVgwN
</commit_message>
<xml_diff>
--- a/sesion10/Sesion10_Metodos_de_Solucion.pptx
+++ b/sesion10/Sesion10_Metodos_de_Solucion.pptx
@@ -7594,27 +7594,27 @@
         </p:nvSpPr>
         <p:spPr>
           <a:xfrm>
-            <a:off x="1325880" y="1737360"/>
-            <a:ext cx="4381348" cy="640080"/>
-          </a:xfrm>
-          <a:prstGeom prst="rect">
-            <a:avLst/>
-          </a:prstGeom>
-          <a:noFill/>
-          <a:ln/>
-        </p:spPr>
-        <p:txBody>
-          <a:bodyPr wrap="square" lIns="0" tIns="0" rIns="0" bIns="0" rtlCol="0" anchor="t"/>
+            <a:off x="1325880" y="1783080"/>
+            <a:ext cx="4381348" cy="1051560"/>
+          </a:xfrm>
+          <a:prstGeom prst="rect">
+            <a:avLst/>
+          </a:prstGeom>
+          <a:noFill/>
+          <a:ln/>
+        </p:spPr>
+        <p:txBody>
+          <a:bodyPr wrap="square" lIns="0" tIns="0" rIns="0" bIns="0" rtlCol="0" anchor="ctr"/>
           <a:lstStyle/>
           <a:p>
             <a:pPr indent="0" marL="0">
               <a:lnSpc>
-                <a:spcPct val="110000"/>
+                <a:spcPct val="115000"/>
               </a:lnSpc>
               <a:buNone/>
             </a:pPr>
             <a:r>
-              <a:rPr lang="en-US" sz="1300" b="1" dirty="0">
+              <a:rPr lang="en-US" sz="1500" b="1" dirty="0">
                 <a:solidFill>
                   <a:srgbClr val="F8FAFC"/>
                 </a:solidFill>
@@ -7624,55 +7624,13 @@
               </a:rPr>
               <a:t>¿Qué operador aniquila un polinomio de grado k?</a:t>
             </a:r>
-            <a:endParaRPr lang="en-US" sz="1300" dirty="0"/>
-          </a:p>
-        </p:txBody>
-      </p:sp>
-      <p:sp>
-        <p:nvSpPr>
-          <p:cNvPr id="8" name="Text 6"/>
-          <p:cNvSpPr/>
-          <p:nvPr/>
-        </p:nvSpPr>
-        <p:spPr>
-          <a:xfrm>
-            <a:off x="822960" y="2514600"/>
-            <a:ext cx="4838548" cy="411480"/>
-          </a:xfrm>
-          <a:prstGeom prst="rect">
-            <a:avLst/>
-          </a:prstGeom>
-          <a:noFill/>
-          <a:ln/>
-        </p:spPr>
-        <p:txBody>
-          <a:bodyPr wrap="square" lIns="0" tIns="0" rIns="0" bIns="0" rtlCol="0" anchor="t"/>
-          <a:lstStyle/>
-          <a:p>
-            <a:pPr algn="l" indent="0" marL="0">
-              <a:lnSpc>
-                <a:spcPct val="112000"/>
-              </a:lnSpc>
-              <a:buNone/>
-            </a:pPr>
-            <a:r>
-              <a:rPr lang="en-US" sz="1200" dirty="0">
-                <a:solidFill>
-                  <a:srgbClr val="CBD5E1"/>
-                </a:solidFill>
-                <a:latin typeface="Calibri" pitchFamily="34" charset="0"/>
-                <a:ea typeface="Calibri" pitchFamily="34" charset="-122"/>
-                <a:cs typeface="Calibri" pitchFamily="34" charset="-120"/>
-              </a:rPr>
-              <a:t>→ Dᵏ⁺¹</a:t>
-            </a:r>
-            <a:endParaRPr lang="en-US" sz="1200" dirty="0"/>
-          </a:p>
-        </p:txBody>
-      </p:sp>
-      <p:sp>
-        <p:nvSpPr>
-          <p:cNvPr id="9" name="Shape 7"/>
+            <a:endParaRPr lang="en-US" sz="1500" dirty="0"/>
+          </a:p>
+        </p:txBody>
+      </p:sp>
+      <p:sp>
+        <p:nvSpPr>
+          <p:cNvPr id="8" name="Shape 6"/>
           <p:cNvSpPr/>
           <p:nvPr/>
         </p:nvSpPr>
@@ -7699,7 +7657,7 @@
       </p:sp>
       <p:sp>
         <p:nvSpPr>
-          <p:cNvPr id="10" name="Shape 8"/>
+          <p:cNvPr id="9" name="Shape 7"/>
           <p:cNvSpPr/>
           <p:nvPr/>
         </p:nvSpPr>
@@ -7724,7 +7682,7 @@
       </p:sp>
       <p:sp>
         <p:nvSpPr>
-          <p:cNvPr id="11" name="Text 9"/>
+          <p:cNvPr id="10" name="Text 8"/>
           <p:cNvSpPr/>
           <p:nvPr/>
         </p:nvSpPr>
@@ -7763,33 +7721,33 @@
       </p:sp>
       <p:sp>
         <p:nvSpPr>
-          <p:cNvPr id="12" name="Text 10"/>
-          <p:cNvSpPr/>
-          <p:nvPr/>
-        </p:nvSpPr>
-        <p:spPr>
-          <a:xfrm>
-            <a:off x="7033108" y="1737360"/>
-            <a:ext cx="4381348" cy="640080"/>
-          </a:xfrm>
-          <a:prstGeom prst="rect">
-            <a:avLst/>
-          </a:prstGeom>
-          <a:noFill/>
-          <a:ln/>
-        </p:spPr>
-        <p:txBody>
-          <a:bodyPr wrap="square" lIns="0" tIns="0" rIns="0" bIns="0" rtlCol="0" anchor="t"/>
+          <p:cNvPr id="11" name="Text 9"/>
+          <p:cNvSpPr/>
+          <p:nvPr/>
+        </p:nvSpPr>
+        <p:spPr>
+          <a:xfrm>
+            <a:off x="7033108" y="1783080"/>
+            <a:ext cx="4381348" cy="1051560"/>
+          </a:xfrm>
+          <a:prstGeom prst="rect">
+            <a:avLst/>
+          </a:prstGeom>
+          <a:noFill/>
+          <a:ln/>
+        </p:spPr>
+        <p:txBody>
+          <a:bodyPr wrap="square" lIns="0" tIns="0" rIns="0" bIns="0" rtlCol="0" anchor="ctr"/>
           <a:lstStyle/>
           <a:p>
             <a:pPr indent="0" marL="0">
               <a:lnSpc>
-                <a:spcPct val="110000"/>
+                <a:spcPct val="115000"/>
               </a:lnSpc>
               <a:buNone/>
             </a:pPr>
             <a:r>
-              <a:rPr lang="en-US" sz="1300" b="1" dirty="0">
+              <a:rPr lang="en-US" sz="1500" b="1" dirty="0">
                 <a:solidFill>
                   <a:srgbClr val="F8FAFC"/>
                 </a:solidFill>
@@ -7799,55 +7757,13 @@
               </a:rPr>
               <a:t>¿Qué operador aniquila eʳˣ?</a:t>
             </a:r>
-            <a:endParaRPr lang="en-US" sz="1300" dirty="0"/>
-          </a:p>
-        </p:txBody>
-      </p:sp>
-      <p:sp>
-        <p:nvSpPr>
-          <p:cNvPr id="13" name="Text 11"/>
-          <p:cNvSpPr/>
-          <p:nvPr/>
-        </p:nvSpPr>
-        <p:spPr>
-          <a:xfrm>
-            <a:off x="6530188" y="2514600"/>
-            <a:ext cx="4838548" cy="411480"/>
-          </a:xfrm>
-          <a:prstGeom prst="rect">
-            <a:avLst/>
-          </a:prstGeom>
-          <a:noFill/>
-          <a:ln/>
-        </p:spPr>
-        <p:txBody>
-          <a:bodyPr wrap="square" lIns="0" tIns="0" rIns="0" bIns="0" rtlCol="0" anchor="t"/>
-          <a:lstStyle/>
-          <a:p>
-            <a:pPr algn="l" indent="0" marL="0">
-              <a:lnSpc>
-                <a:spcPct val="112000"/>
-              </a:lnSpc>
-              <a:buNone/>
-            </a:pPr>
-            <a:r>
-              <a:rPr lang="en-US" sz="1200" dirty="0">
-                <a:solidFill>
-                  <a:srgbClr val="CBD5E1"/>
-                </a:solidFill>
-                <a:latin typeface="Calibri" pitchFamily="34" charset="0"/>
-                <a:ea typeface="Calibri" pitchFamily="34" charset="-122"/>
-                <a:cs typeface="Calibri" pitchFamily="34" charset="-120"/>
-              </a:rPr>
-              <a:t>→ (D−r)</a:t>
-            </a:r>
-            <a:endParaRPr lang="en-US" sz="1200" dirty="0"/>
-          </a:p>
-        </p:txBody>
-      </p:sp>
-      <p:sp>
-        <p:nvSpPr>
-          <p:cNvPr id="14" name="Shape 12"/>
+            <a:endParaRPr lang="en-US" sz="1500" dirty="0"/>
+          </a:p>
+        </p:txBody>
+      </p:sp>
+      <p:sp>
+        <p:nvSpPr>
+          <p:cNvPr id="12" name="Shape 10"/>
           <p:cNvSpPr/>
           <p:nvPr/>
         </p:nvSpPr>
@@ -7874,7 +7790,7 @@
       </p:sp>
       <p:sp>
         <p:nvSpPr>
-          <p:cNvPr id="15" name="Shape 13"/>
+          <p:cNvPr id="13" name="Shape 11"/>
           <p:cNvSpPr/>
           <p:nvPr/>
         </p:nvSpPr>
@@ -7899,7 +7815,7 @@
       </p:sp>
       <p:sp>
         <p:nvSpPr>
-          <p:cNvPr id="16" name="Text 14"/>
+          <p:cNvPr id="14" name="Text 12"/>
           <p:cNvSpPr/>
           <p:nvPr/>
         </p:nvSpPr>
@@ -7938,33 +7854,33 @@
       </p:sp>
       <p:sp>
         <p:nvSpPr>
-          <p:cNvPr id="17" name="Text 15"/>
-          <p:cNvSpPr/>
-          <p:nvPr/>
-        </p:nvSpPr>
-        <p:spPr>
-          <a:xfrm>
-            <a:off x="1325880" y="3383280"/>
-            <a:ext cx="4381348" cy="640080"/>
-          </a:xfrm>
-          <a:prstGeom prst="rect">
-            <a:avLst/>
-          </a:prstGeom>
-          <a:noFill/>
-          <a:ln/>
-        </p:spPr>
-        <p:txBody>
-          <a:bodyPr wrap="square" lIns="0" tIns="0" rIns="0" bIns="0" rtlCol="0" anchor="t"/>
+          <p:cNvPr id="15" name="Text 13"/>
+          <p:cNvSpPr/>
+          <p:nvPr/>
+        </p:nvSpPr>
+        <p:spPr>
+          <a:xfrm>
+            <a:off x="1325880" y="3429000"/>
+            <a:ext cx="4381348" cy="1051560"/>
+          </a:xfrm>
+          <a:prstGeom prst="rect">
+            <a:avLst/>
+          </a:prstGeom>
+          <a:noFill/>
+          <a:ln/>
+        </p:spPr>
+        <p:txBody>
+          <a:bodyPr wrap="square" lIns="0" tIns="0" rIns="0" bIns="0" rtlCol="0" anchor="ctr"/>
           <a:lstStyle/>
           <a:p>
             <a:pPr indent="0" marL="0">
               <a:lnSpc>
-                <a:spcPct val="110000"/>
+                <a:spcPct val="115000"/>
               </a:lnSpc>
               <a:buNone/>
             </a:pPr>
             <a:r>
-              <a:rPr lang="en-US" sz="1300" b="1" dirty="0">
+              <a:rPr lang="en-US" sz="1500" b="1" dirty="0">
                 <a:solidFill>
                   <a:srgbClr val="F8FAFC"/>
                 </a:solidFill>
@@ -7974,55 +7890,13 @@
               </a:rPr>
               <a:t>Si tengo xeʳˣ, ¿por qué (D−r) ya no basta?</a:t>
             </a:r>
-            <a:endParaRPr lang="en-US" sz="1300" dirty="0"/>
-          </a:p>
-        </p:txBody>
-      </p:sp>
-      <p:sp>
-        <p:nvSpPr>
-          <p:cNvPr id="18" name="Text 16"/>
-          <p:cNvSpPr/>
-          <p:nvPr/>
-        </p:nvSpPr>
-        <p:spPr>
-          <a:xfrm>
-            <a:off x="822960" y="4160520"/>
-            <a:ext cx="4838548" cy="411480"/>
-          </a:xfrm>
-          <a:prstGeom prst="rect">
-            <a:avLst/>
-          </a:prstGeom>
-          <a:noFill/>
-          <a:ln/>
-        </p:spPr>
-        <p:txBody>
-          <a:bodyPr wrap="square" lIns="0" tIns="0" rIns="0" bIns="0" rtlCol="0" anchor="t"/>
-          <a:lstStyle/>
-          <a:p>
-            <a:pPr algn="l" indent="0" marL="0">
-              <a:lnSpc>
-                <a:spcPct val="112000"/>
-              </a:lnSpc>
-              <a:buNone/>
-            </a:pPr>
-            <a:r>
-              <a:rPr lang="en-US" sz="1200" dirty="0">
-                <a:solidFill>
-                  <a:srgbClr val="CBD5E1"/>
-                </a:solidFill>
-                <a:latin typeface="Calibri" pitchFamily="34" charset="0"/>
-                <a:ea typeface="Calibri" pitchFamily="34" charset="-122"/>
-                <a:cs typeface="Calibri" pitchFamily="34" charset="-120"/>
-              </a:rPr>
-              <a:t>→ (D−r)² — una aplicación sola no alcanza el factor x</a:t>
-            </a:r>
-            <a:endParaRPr lang="en-US" sz="1200" dirty="0"/>
-          </a:p>
-        </p:txBody>
-      </p:sp>
-      <p:sp>
-        <p:nvSpPr>
-          <p:cNvPr id="19" name="Shape 17"/>
+            <a:endParaRPr lang="en-US" sz="1500" dirty="0"/>
+          </a:p>
+        </p:txBody>
+      </p:sp>
+      <p:sp>
+        <p:nvSpPr>
+          <p:cNvPr id="16" name="Shape 14"/>
           <p:cNvSpPr/>
           <p:nvPr/>
         </p:nvSpPr>
@@ -8049,7 +7923,7 @@
       </p:sp>
       <p:sp>
         <p:nvSpPr>
-          <p:cNvPr id="20" name="Shape 18"/>
+          <p:cNvPr id="17" name="Shape 15"/>
           <p:cNvSpPr/>
           <p:nvPr/>
         </p:nvSpPr>
@@ -8074,7 +7948,7 @@
       </p:sp>
       <p:sp>
         <p:nvSpPr>
-          <p:cNvPr id="21" name="Text 19"/>
+          <p:cNvPr id="18" name="Text 16"/>
           <p:cNvSpPr/>
           <p:nvPr/>
         </p:nvSpPr>
@@ -8113,33 +7987,33 @@
       </p:sp>
       <p:sp>
         <p:nvSpPr>
-          <p:cNvPr id="22" name="Text 20"/>
-          <p:cNvSpPr/>
-          <p:nvPr/>
-        </p:nvSpPr>
-        <p:spPr>
-          <a:xfrm>
-            <a:off x="7033108" y="3383280"/>
-            <a:ext cx="4381348" cy="640080"/>
-          </a:xfrm>
-          <a:prstGeom prst="rect">
-            <a:avLst/>
-          </a:prstGeom>
-          <a:noFill/>
-          <a:ln/>
-        </p:spPr>
-        <p:txBody>
-          <a:bodyPr wrap="square" lIns="0" tIns="0" rIns="0" bIns="0" rtlCol="0" anchor="t"/>
+          <p:cNvPr id="19" name="Text 17"/>
+          <p:cNvSpPr/>
+          <p:nvPr/>
+        </p:nvSpPr>
+        <p:spPr>
+          <a:xfrm>
+            <a:off x="7033108" y="3429000"/>
+            <a:ext cx="4381348" cy="1051560"/>
+          </a:xfrm>
+          <a:prstGeom prst="rect">
+            <a:avLst/>
+          </a:prstGeom>
+          <a:noFill/>
+          <a:ln/>
+        </p:spPr>
+        <p:txBody>
+          <a:bodyPr wrap="square" lIns="0" tIns="0" rIns="0" bIns="0" rtlCol="0" anchor="ctr"/>
           <a:lstStyle/>
           <a:p>
             <a:pPr indent="0" marL="0">
               <a:lnSpc>
-                <a:spcPct val="110000"/>
+                <a:spcPct val="115000"/>
               </a:lnSpc>
               <a:buNone/>
             </a:pPr>
             <a:r>
-              <a:rPr lang="en-US" sz="1300" b="1" dirty="0">
+              <a:rPr lang="en-US" sz="1500" b="1" dirty="0">
                 <a:solidFill>
                   <a:srgbClr val="F8FAFC"/>
                 </a:solidFill>
@@ -8149,55 +8023,13 @@
               </a:rPr>
               <a:t>Si g(x)=3x+e²ˣ, ¿cómo aniquilan toda la suma?</a:t>
             </a:r>
-            <a:endParaRPr lang="en-US" sz="1300" dirty="0"/>
-          </a:p>
-        </p:txBody>
-      </p:sp>
-      <p:sp>
-        <p:nvSpPr>
-          <p:cNvPr id="23" name="Text 21"/>
-          <p:cNvSpPr/>
-          <p:nvPr/>
-        </p:nvSpPr>
-        <p:spPr>
-          <a:xfrm>
-            <a:off x="6530188" y="4160520"/>
-            <a:ext cx="4838548" cy="411480"/>
-          </a:xfrm>
-          <a:prstGeom prst="rect">
-            <a:avLst/>
-          </a:prstGeom>
-          <a:noFill/>
-          <a:ln/>
-        </p:spPr>
-        <p:txBody>
-          <a:bodyPr wrap="square" lIns="0" tIns="0" rIns="0" bIns="0" rtlCol="0" anchor="t"/>
-          <a:lstStyle/>
-          <a:p>
-            <a:pPr algn="l" indent="0" marL="0">
-              <a:lnSpc>
-                <a:spcPct val="112000"/>
-              </a:lnSpc>
-              <a:buNone/>
-            </a:pPr>
-            <a:r>
-              <a:rPr lang="en-US" sz="1200" dirty="0">
-                <a:solidFill>
-                  <a:srgbClr val="CBD5E1"/>
-                </a:solidFill>
-                <a:latin typeface="Calibri" pitchFamily="34" charset="0"/>
-                <a:ea typeface="Calibri" pitchFamily="34" charset="-122"/>
-                <a:cs typeface="Calibri" pitchFamily="34" charset="-120"/>
-              </a:rPr>
-              <a:t>→ combinan los anuladores: D²(D−2)</a:t>
-            </a:r>
-            <a:endParaRPr lang="en-US" sz="1200" dirty="0"/>
-          </a:p>
-        </p:txBody>
-      </p:sp>
-      <p:sp>
-        <p:nvSpPr>
-          <p:cNvPr id="24" name="Shape 22"/>
+            <a:endParaRPr lang="en-US" sz="1500" dirty="0"/>
+          </a:p>
+        </p:txBody>
+      </p:sp>
+      <p:sp>
+        <p:nvSpPr>
+          <p:cNvPr id="20" name="Shape 18"/>
           <p:cNvSpPr/>
           <p:nvPr/>
         </p:nvSpPr>
@@ -8224,7 +8056,7 @@
       </p:sp>
       <p:sp>
         <p:nvSpPr>
-          <p:cNvPr id="25" name="Text 23"/>
+          <p:cNvPr id="21" name="Text 19"/>
           <p:cNvSpPr/>
           <p:nvPr/>
         </p:nvSpPr>
@@ -8266,7 +8098,7 @@
       </p:sp>
       <p:sp>
         <p:nvSpPr>
-          <p:cNvPr id="26" name="Text 24"/>
+          <p:cNvPr id="22" name="Text 20"/>
           <p:cNvSpPr/>
           <p:nvPr/>
         </p:nvSpPr>
@@ -8305,7 +8137,7 @@
       </p:sp>
       <p:sp>
         <p:nvSpPr>
-          <p:cNvPr id="27" name="Text 25"/>
+          <p:cNvPr id="23" name="Text 21"/>
           <p:cNvSpPr/>
           <p:nvPr/>
         </p:nvSpPr>

</xml_diff>